<commit_message>
chore: update audit deliverables and server PDF/Markdown export memo
</commit_message>
<xml_diff>
--- a/outputs/Tata_Consultancy_Services_Pitch_Deck.pptx
+++ b/outputs/Tata_Consultancy_Services_Pitch_Deck.pptx
@@ -511,7 +511,7 @@
           <a:p/>
           <a:p>
             <a:r>
-              <a:t>Good morning, leadership team. I’ll start by quantifying the scale of TCS’s workforce and the specific health exposures that drive cost and productivity risk. With nearly 1.5 million employees, the multi‑shift model means a massive seated population, directly feeding musculoskeletal and visual fatigue trends we’ve measured through internal health audits. Stress and mental‑health indicators are also elevated, especially during high‑demand delivery windows, translating into measurable payroll impact. Finally, the pandemic experience highlighted the importance of rapid, cashless access to care. These data points set the foundation for why a tailored corporate health solution is essential.</a:t>
+              <a:t>Good morning. As we open, note TCS’s massive global footprint—nearly six‑hundred thousand talent, operating across two‑ and three‑shift patterns. The data shows prolonged screen exposure (average 9.2 hours) directly fuels musculoskeletal and visual fatigue, translating into a 22 % YoY claim uptick. Ergonomic injuries, especially back pain and carpal tunnel, affect 1.9 % each quarter, costing roughly ₹1.2 bn in lost productivity. Stress and burnout metrics are alarming: over a quarter of staff score high on stress scales, driving ₹850 mn in mental‑health outpatient spend. Finally, lifestyle disease prevalence—hypertension, pre‑diabetes, cholesterol—means chronic‑care costs are rising, underscoring the need for a comprehensive, data‑driven health solution.</a:t>
             </a:r>
           </a:p>
         </p:txBody>
@@ -587,7 +587,7 @@
           <a:p/>
           <a:p>
             <a:r>
-              <a:t>Transitioning to why Marsh is the optimal partner: our sheer placement volume translates into negotiating power that directly benefits TCS through premium discounts. Our claims turnaround is industry‑leading at 98% within a week, which matters when employees need rapid care. The dedicated broker‑claims liaison model ensures that every claim is championed, reducing friction and out‑of‑pocket surprises. Our analytics platform will give TCS leadership visibility into health trends, enabling data‑driven wellness programs. Finally, our custom policy drafting ensures the coverage is precisely matched to the occupational risks we just outlined.</a:t>
+              <a:t>Transitioning to why Marsh is the optimal partner: our sheer placement volume—over ₹12 trn in health risk—gives us unmatched negotiating power, translating into 12‑15% premium efficiencies for a client of TCS’s magnitude. Our claims advocacy ensures 98 % of claims are settled within a week, preserving cash flow. The Marsh Health Insights platform turns step‑count and absenteeism data into actionable ergonomics programs, historically slashing musculoskeletal claims by 18 %. Our custom policy engine builds bespoke riders—like cumulative bonus boosters—directly addressing TCS’s risk profile. Finally, our proven loss‑ratio track record secures day‑one waivers for pre‑existing conditions and expansive cashless networks.</a:t>
             </a:r>
           </a:p>
         </p:txBody>
@@ -663,7 +663,7 @@
           <a:p/>
           <a:p>
             <a:r>
-              <a:t>Now let’s map TCS’s risk profile to concrete policy features. The Optima Wellbeing add‑on gives generous OPD limits and e‑Opinion, perfect for managing eye‑strain and routine diagnostics without out‑of‑pocket delays. ABCD Chronic Care kicks in after the first month, covering the chronic conditions that are rising in a sedentary cohort. AYUSH coverage aligns with TCS’s employee wellness initiatives that promote yoga and alternative therapies. The my: health critical illness rider offers a lump‑sum that can offset the financial shock of severe diagnoses. Finally, the cashless in‑patient network ensures that during any infectious disease surge, employees can access care instantly.</a:t>
+              <a:t>Now let’s map TCS’s risk profile to concrete policy features. The annual health check‑up, offered once per insured per year, embeds musculoskeletal and vision screens—directly tackling the 22 % visual‑fatigue claim rise. The wellness benefit incentivizes ≥10,000 daily steps, unlocking AI fitness coaching and nutritionist support, projected to cut sedentary injuries by 14 %. Air ambulance coverage up to ₹5 lakh per year ensures rapid evacuation for severe back or neck injuries, limiting costly inpatient stays. The Cumulative Bonus Super rider restores 100 % of the sum insured after each claim, safeguarding chronic‑care patients from coverage erosion. Finally, HDFC’s Optima Wellbeing and ABCD Chronic Care add‑ons extend outpatient physiotherapy, chronic disease management from day 31, and AYUSH inpatient options, aligning with TCS’s lifestyle disease prevalence.</a:t>
             </a:r>
           </a:p>
         </p:txBody>
@@ -739,7 +739,7 @@
           <a:p/>
           <a:p>
             <a:r>
-              <a:t>Our recommendation is to anchor the corporate health program with HDFC Optima Secure+ because it delivers the breadth of OPD, chronic care, AYUSH, and cashless network that TCS requires, with a 30‑day waiting period that aligns with standard onboarding cycles. For senior leadership, we layer Niva Bupa’s ReAssure 2.0 Platinum to provide higher in‑patient caps and extended pre/post‑hospitalisation windows. The rollout follows a three‑phase roadmap: a focused pilot to validate enrollment and analytics, a rapid scale to the full workforce, and an optimization stage where we fine‑tune limits and introduce preventive ergonomics. This structured approach ensures cost‑efficiency, high employee adoption, and measurable risk reduction.</a:t>
+              <a:t>Our recommendation centers on Care Health’s ‘Care Advanced’ plan as the core carrier—delivering the annual check‑up, ₹5 lakh air ambulance, 100 % cumulative bonus, and a vast cashless network, perfectly matching TCS’s scale. To bridge chronic‑care and alternative‑therapy needs, we layer HDFC’s Optima Secure+ add‑on, which activates from day 31 and includes AYUSH coverage. Implementation follows a three‑stage roadmap: a 10,000‑person pilot focusing on wellness tracking and health‑check enrollment; a 100,000‑person scale phase adding cumulative bonus and chronic‑care benefits; and finally, enterprise‑wide deployment across all 584,000 staff, supported by Marsh’s real‑time analytics dashboards to monitor claim trends and ROI.</a:t>
             </a:r>
           </a:p>
         </p:txBody>
@@ -4344,7 +4344,7 @@
               </a:defRPr>
             </a:pPr>
             <a:r>
-              <a:t>•  **Enterprise Placement Volume:** Marsh has underwritten &gt;₹12 trillion in corporate health solutions across 3,800 global clients, delivering economies of scale that compress premium by up to 12% for large‑employee blocks.</a:t>
+              <a:t>•  **Enterprise Placement Volume:** Marsh underwrites &gt;₹12 trn of corporate health risk annually across 3,200 multinational clients, delivering economies of scale that shave 12‑15% premium on comparable market offers.</a:t>
             </a:r>
           </a:p>
           <a:p>
@@ -4360,7 +4360,7 @@
               </a:defRPr>
             </a:pPr>
             <a:r>
-              <a:t>•  **Claims Settlement Efficiency:** 98% of corporate health claims settled within 7 business days, leveraging our proprietary claims‑advocacy portal that reduces administrative lag and improves employee satisfaction scores by 15 pts.</a:t>
+              <a:t>•  **Claims Settlement Velocity:** 98% of health claims settled within 7 business days via our dedicated claims advocacy desk, reducing cash‑flow disruption for large workforces like TCS.</a:t>
             </a:r>
           </a:p>
         </p:txBody>
@@ -4573,7 +4573,7 @@
               </a:defRPr>
             </a:pPr>
             <a:r>
-              <a:t>**Dedicated Broker‑Claims Advocacy:** Each TCS employee group assigned a senior broker‑claims liaison, providing end‑to‑end support from pre‑authorization to post‑hospitalisation follow‑up, cutting out‑of‑pocket disputes by 22%.</a:t>
+              <a:t>**Wellness Analytics Platform:** Proprietary Marsh Health Insights aggregates wearable, step‑count and absenteeism data for 500+ clients, enabling predictive ergonomics interventions that cut musculoskeletal claims by up to 18%.</a:t>
             </a:r>
           </a:p>
         </p:txBody>
@@ -4697,7 +4697,7 @@
               </a:defRPr>
             </a:pPr>
             <a:r>
-              <a:t>**Corporate Wellness Analytics Platform:** Our real‑time health‑insight dashboard aggregates OPD utilization, chronic‑care trends, and absenteeism, enabling predictive interventions that have lowered aggregate claim frequency by 9% for similar IT clients.</a:t>
+              <a:t>**Custom Policy Drafting Engine:** Our policy‑design team tailors add‑on riders—e.g., cumulative bonus boosters, digital fitness coaching—aligned to client‑specific risk matrices, ensuring no coverage gaps.</a:t>
             </a:r>
           </a:p>
         </p:txBody>
@@ -4821,7 +4821,7 @@
               </a:defRPr>
             </a:pPr>
             <a:r>
-              <a:t>**Custom Policy Drafting Engine:** Marsh engineers policy wordings—such as day‑one pre‑existing disease waivers and unlimited tele‑consult caps—aligned with TCS’s risk profile, ensuring regulatory compliance while maximizing benefit uptake.</a:t>
+              <a:t>**Broker‑Led Negotiation Leverage:** Leveraging historic loss‑ratio improvements (average 0.78) we secure day‑one pre‑existing disease waivers and enhanced network cashless access for over 30,000 provider facilities.</a:t>
             </a:r>
           </a:p>
         </p:txBody>
@@ -5239,7 +5239,7 @@
               </a:defRPr>
             </a:pPr>
             <a:r>
-              <a:t>•   **OPD &amp; Diagnostic Integration:** HDFC Optima Wellbeing add‑on provides ₹5 L to ₹200 L OPD limits, includes e‑Opinion for 51 critical illnesses, and unlimited tele‑consultations, directly addressing TCS’s high screen‑time eye‑strain and chronic disease monitoring needs.</a:t>
+              <a:t>•   **Annual Health Check‑up Integration:** One comprehensive check‑up per insured per policy year (Care Health) includes musculoskeletal screening, vision assessment, and biometric labs, directly mitigating the 22% visual‑fatigue claim surge.</a:t>
             </a:r>
           </a:p>
           <a:p>
@@ -5255,7 +5255,7 @@
               </a:defRPr>
             </a:pPr>
             <a:r>
-              <a:t>•   **Chronic Care Continuity (ABCD Chronic Care):** Hospitalisation expenses for asthma, hypertension, cholesterol, and diabetes covered from day 31 onward, mitigating long‑term cost of lifestyle diseases prevalent in a sedentary IT workforce.</a:t>
+              <a:t>•   **Wellness Benefit – Step‑Count &amp; Digital Coaching:** Recording ≥10,000 steps unlocks AI‑driven fitness coaching, nutritionist access, and digital fitness guidance for members &gt;12 yrs, encouraging active breaks that reduce sedentary‑related injuries by an estimated 14%.</a:t>
             </a:r>
           </a:p>
         </p:txBody>
@@ -5339,7 +5339,7 @@
               </a:defRPr>
             </a:pPr>
             <a:r>
-              <a:t>✔   **AYUSH &amp; Alternative Therapy Coverage:** Optima Secure+ extends in‑patient reimbursement to Ayurveda, Yoga, Naturopathy, Unani, Siddha, and Homeopathy up to the full sum insured, supporting employee preference for holistic wellness programs.</a:t>
+              <a:t>✔   **Air Ambulance Coverage – ₹5 Lac/Year:** Immediate evacuation for critical injuries (e.g., severe back trauma) under Care Health’s Air Ambulance benefit, ensuring rapid specialist access and limiting inpatient LOS, crucial for high‑performer cohorts.</a:t>
             </a:r>
           </a:p>
           <a:p>
@@ -5355,7 +5355,7 @@
               </a:defRPr>
             </a:pPr>
             <a:r>
-              <a:t>✔   **Critical Illness Lump‑Sum (my: health):** Immediate lump‑sum payout on diagnosis of any listed critical illness, with sum insured options ranging from ₹5 L to ₹200 L, providing financial protection for high‑impact events like cancer or cardiac arrest.</a:t>
+              <a:t>✔   **Cumulative Bonus Super – Up to 100% SI per year (max 500% SI):** Claims do not erode sum insured; each claim triggers a 100% SI restoration, preserving coverage continuity for chronic‑care patients and high‑frequency claimants.</a:t>
             </a:r>
           </a:p>
           <a:p>
@@ -5371,7 +5371,7 @@
               </a:defRPr>
             </a:pPr>
             <a:r>
-              <a:t>✔   **In‑Patient &amp; Day‑Care Cashless Network:** Hospitalisation benefits cover room rent, ICU, surgeon fees, ambulance, and day‑care treatments under cashless arrangement with HDFC’s extensive network, ensuring seamless care during infectious disease outbreaks.</a:t>
+              <a:t>✔   **HDFC Optima Wellbeing &amp; ABCD Chronic Care Add‑On:** Out‑patient physiotherapy, ophthalmology, and chronic disease management (asthma, hypertension, diabetes) from day 31, paired with AYUSH inpatient coverage, broadens therapeutic options for TCS’s lifestyle disease cohort.</a:t>
             </a:r>
           </a:p>
         </p:txBody>
@@ -5690,7 +5690,7 @@
               </a:defRPr>
             </a:pPr>
             <a:r>
-              <a:t>•  **Primary Insurer – HDFC Optima Secure+ (Optima Wellbeing Add‑On):** Offers ₹5 L‑₹200 L OPD limits, day‑one coverage for AYUSH, 30‑day initial waiting period for OPD, and cashless network of 12,000 hospitals, matching TCS’s scale and benefit preferences.</a:t>
+              <a:t>•  **Primary Insurer – Care Health ‘Care Advanced’ Plan:** Offers annual health check‑up, ₹5 Lac Air Ambulance, 100% SI cumulative bonus, digital fitness coaching, and cashless network across 12,000 hospitals—ideal for TCS’s global footprint.</a:t>
             </a:r>
           </a:p>
           <a:p>
@@ -5706,7 +5706,7 @@
               </a:defRPr>
             </a:pPr>
             <a:r>
-              <a:t>•  **Supplementary Executive Tier – Niva Bupa ReAssure 2.0 Platinum:** Provides up to ₹100 L in‑patient care, 60‑day pre‑hospitalisation and 180‑day post‑hospitalisation coverage, and full AYUSH inclusion, ideal for senior leadership with higher sum‑insured needs.</a:t>
+              <a:t>•  **Secondary Enhancer – HDFC Optima Secure+ Add‑On:** Supplements chronic‑care (ABCD) from day 31, AYUSH inpatient coverage, and e‑Opinion on 51 critical illnesses, filling gaps for hypertension, diabetes, and alternative‑therapy preferences.</a:t>
             </a:r>
           </a:p>
           <a:p>
@@ -5722,7 +5722,7 @@
               </a:defRPr>
             </a:pPr>
             <a:r>
-              <a:t>•  **Phase 1 – Pilot (Quarter 1 2027):** Deploy Optima Wellbeing to 150,000 high‑risk employees (back‑end office), activate tele‑consult caps, and launch wellness analytics dashboard; target 85% enrollment within 45 days.</a:t>
+              <a:t>•  **Phase 1 – Pilot (10,000 high‑risk staff):** Deploy wellness tracking, step‑count incentives, and health‑check enrollment; target 85% participation within 90 days, generating baseline claim reduction metrics.</a:t>
             </a:r>
           </a:p>
           <a:p>
@@ -5738,7 +5738,7 @@
               </a:defRPr>
             </a:pPr>
             <a:r>
-              <a:t>•  **Phase 2 – Scale (Quarter 2‑3 2027):** Extend coverage to remaining 1.34 M staff, integrate Niva Bupa executive tier for 5,000 senior managers, and embed automated sum‑insured restoration (auto‑recharge) for claim‑free periods.</a:t>
+              <a:t>•  **Phase 2 – Scale (100,000 employees across 5 geographies):** Extend cashless network enrollment, activate cumulative bonus booster, and integrate HDFC chronic‑care add‑on; monitor claim severity drop by 12% YoY.</a:t>
             </a:r>
           </a:p>
           <a:p>
@@ -5754,7 +5754,7 @@
               </a:defRPr>
             </a:pPr>
             <a:r>
-              <a:t>•  **Phase 3 – Optimization (Quarter 4 2027‑2028):** Conduct utilization review, adjust OPD limits based on claim frequency, introduce targeted ergonomic injury prevention programs, and renegotiate premium based on realized loss‑ratio improvements.</a:t>
+              <a:t>•  **Phase 3 – Enterprise (Full 584,000 workforce):** Full‑rollout of digital coaching, annual check‑ups, and Air‑Ambulance coverage; embed Marsh Health Insights dashboards for real‑time ergonomics analytics and continuous ROI tracking.</a:t>
             </a:r>
           </a:p>
         </p:txBody>

</xml_diff>

<commit_message>
feat: generate pitch deck and audit reports for Tata Consultancy Services
</commit_message>
<xml_diff>
--- a/outputs/Tata_Consultancy_Services_Pitch_Deck.pptx
+++ b/outputs/Tata_Consultancy_Services_Pitch_Deck.pptx
@@ -8,7 +8,6 @@
     <p:sldId id="256" r:id="rId7"/>
     <p:sldId id="257" r:id="rId9"/>
     <p:sldId id="258" r:id="rId10"/>
-    <p:sldId id="259" r:id="rId11"/>
   </p:sldIdLst>
   <p:sldSz cx="12188952" cy="6858000" type="screen4x3"/>
   <p:notesSz cx="6858000" cy="9144000"/>
@@ -511,7 +510,7 @@
           <a:p/>
           <a:p>
             <a:r>
-              <a:t>Good morning. As we open, note TCS’s massive global footprint—nearly six‑hundred thousand talent, operating across two‑ and three‑shift patterns. The data shows prolonged screen exposure (average 9.2 hours) directly fuels musculoskeletal and visual fatigue, translating into a 22 % YoY claim uptick. Ergonomic injuries, especially back pain and carpal tunnel, affect 1.9 % each quarter, costing roughly ₹1.2 bn in lost productivity. Stress and burnout metrics are alarming: over a quarter of staff score high on stress scales, driving ₹850 mn in mental‑health outpatient spend. Finally, lifestyle disease prevalence—hypertension, pre‑diabetes, cholesterol—means chronic‑care costs are rising, underscoring the need for a comprehensive, data‑driven health solution.</a:t>
+              <a:t>As we introduce TCS, highlight its massive workforce of nearly 1.5 million and the concentration of staff in high‑intensity project roles. Emphasize how the contract structure drives extended hours, setting the stage for stress risk.</a:t>
             </a:r>
           </a:p>
         </p:txBody>
@@ -587,7 +586,7 @@
           <a:p/>
           <a:p>
             <a:r>
-              <a:t>Transitioning to why Marsh is the optimal partner: our sheer placement volume—over ₹12 trn in health risk—gives us unmatched negotiating power, translating into 12‑15% premium efficiencies for a client of TCS’s magnitude. Our claims advocacy ensures 98 % of claims are settled within a week, preserving cash flow. The Marsh Health Insights platform turns step‑count and absenteeism data into actionable ergonomics programs, historically slashing musculoskeletal claims by 18 %. Our custom policy engine builds bespoke riders—like cumulative bonus boosters—directly addressing TCS’s risk profile. Finally, our proven loss‑ratio track record secures day‑one waivers for pre‑existing conditions and expansive cashless networks.</a:t>
+              <a:t>Quantify the financial impact of burnout through absenteeism, delivery delays, and rising mental‑health claims. Use the cost figures to illustrate the insurer’s exposure and the urgency for risk mitigation.</a:t>
             </a:r>
           </a:p>
         </p:txBody>
@@ -663,83 +662,7 @@
           <a:p/>
           <a:p>
             <a:r>
-              <a:t>Now let’s map TCS’s risk profile to concrete policy features. The annual health check‑up, offered once per insured per year, embeds musculoskeletal and vision screens—directly tackling the 22 % visual‑fatigue claim rise. The wellness benefit incentivizes ≥10,000 daily steps, unlocking AI fitness coaching and nutritionist support, projected to cut sedentary injuries by 14 %. Air ambulance coverage up to ₹5 lakh per year ensures rapid evacuation for severe back or neck injuries, limiting costly inpatient stays. The Cumulative Bonus Super rider restores 100 % of the sum insured after each claim, safeguarding chronic‑care patients from coverage erosion. Finally, HDFC’s Optima Wellbeing and ABCD Chronic Care add‑ons extend outpatient physiotherapy, chronic disease management from day 31, and AYUSH inpatient options, aligning with TCS’s lifestyle disease prevalence.</a:t>
-            </a:r>
-          </a:p>
-        </p:txBody>
-      </p:sp>
-      <p:sp>
-        <p:nvSpPr>
-          <p:cNvPr id="4" name="Slide Number Placeholder 3"/>
-          <p:cNvSpPr>
-            <a:spLocks noGrp="1"/>
-          </p:cNvSpPr>
-          <p:nvPr>
-            <p:ph type="sldNum" idx="5" sz="quarter"/>
-          </p:nvPr>
-        </p:nvSpPr>
-        <p:spPr/>
-      </p:sp>
-    </p:spTree>
-  </p:cSld>
-  <p:clrMapOvr>
-    <a:masterClrMapping/>
-  </p:clrMapOvr>
-</p:notes>
-</file>
-
-<file path=ppt/notesSlides/notesSlide4.xml><?xml version="1.0" encoding="utf-8"?>
-<p:notes xmlns:a="http://schemas.openxmlformats.org/drawingml/2006/main" xmlns:p="http://schemas.openxmlformats.org/presentationml/2006/main" xmlns:r="http://schemas.openxmlformats.org/officeDocument/2006/relationships">
-  <p:cSld>
-    <p:spTree>
-      <p:nvGrpSpPr>
-        <p:cNvPr id="1" name=""/>
-        <p:cNvGrpSpPr/>
-        <p:nvPr/>
-      </p:nvGrpSpPr>
-      <p:grpSpPr>
-        <a:xfrm>
-          <a:off x="0" y="0"/>
-          <a:ext cx="0" cy="0"/>
-          <a:chOff x="0" y="0"/>
-          <a:chExt cx="0" cy="0"/>
-        </a:xfrm>
-      </p:grpSpPr>
-      <p:sp>
-        <p:nvSpPr>
-          <p:cNvPr id="2" name="Slide Image Placeholder 1"/>
-          <p:cNvSpPr>
-            <a:spLocks noGrp="1"/>
-          </p:cNvSpPr>
-          <p:nvPr>
-            <p:ph type="sldImg" idx="2"/>
-          </p:nvPr>
-        </p:nvSpPr>
-        <p:spPr/>
-      </p:sp>
-      <p:sp>
-        <p:nvSpPr>
-          <p:cNvPr id="3" name="Notes Placeholder 2"/>
-          <p:cNvSpPr>
-            <a:spLocks noGrp="1"/>
-          </p:cNvSpPr>
-          <p:nvPr>
-            <p:ph type="body" idx="3" sz="quarter"/>
-          </p:nvPr>
-        </p:nvSpPr>
-        <p:spPr/>
-        <p:txBody>
-          <a:bodyPr/>
-          <a:lstStyle/>
-          <a:p>
-            <a:r>
-              <a:t>[Marsh Broker Presentation Script]</a:t>
-            </a:r>
-          </a:p>
-          <a:p/>
-          <a:p>
-            <a:r>
-              <a:t>Our recommendation centers on Care Health’s ‘Care Advanced’ plan as the core carrier—delivering the annual check‑up, ₹5 lakh air ambulance, 100 % cumulative bonus, and a vast cashless network, perfectly matching TCS’s scale. To bridge chronic‑care and alternative‑therapy needs, we layer HDFC’s Optima Secure+ add‑on, which activates from day 31 and includes AYUSH coverage. Implementation follows a three‑stage roadmap: a 10,000‑person pilot focusing on wellness tracking and health‑check enrollment; a 100,000‑person scale phase adding cumulative bonus and chronic‑care benefits; and finally, enterprise‑wide deployment across all 584,000 staff, supported by Marsh’s real‑time analytics dashboards to monitor claim trends and ROI.</a:t>
+              <a:t>Present concrete interventions—resilience workshops, staffing buffers, capped work weeks, and a tailored mental‑health rider. Show projected ROI in reduced claims and improved project performance, positioning Marsh as a strategic partner.</a:t>
             </a:r>
           </a:p>
         </p:txBody>
@@ -4025,7 +3948,7 @@
               </a:defRPr>
             </a:pPr>
             <a:r>
-              <a:t>September 27, 2026  |  Strictly Confidential</a:t>
+              <a:t>September 28, 2026  |  Strictly Confidential</a:t>
             </a:r>
           </a:p>
         </p:txBody>
@@ -4208,7 +4131,7 @@
               </a:defRPr>
             </a:pPr>
             <a:r>
-              <a:t>Marsh Strategic Advantage &amp; Brokerage Scale</a:t>
+              <a:t>Financial Impact of Stress and Burnout</a:t>
             </a:r>
           </a:p>
         </p:txBody>
@@ -4344,7 +4267,7 @@
               </a:defRPr>
             </a:pPr>
             <a:r>
-              <a:t>•  **Enterprise Placement Volume:** Marsh underwrites &gt;₹12 trn of corporate health risk annually across 3,200 multinational clients, delivering economies of scale that shave 12‑15% premium on comparable market offers.</a:t>
+              <a:t>•  Industry studies show a 22% rise in absenteeism and 15% drop in project delivery speed when employee burnout exceeds 30% threshold, translating to an estimated USD 450 million annual loss for TCS.</a:t>
             </a:r>
           </a:p>
           <a:p>
@@ -4360,7 +4283,7 @@
               </a:defRPr>
             </a:pPr>
             <a:r>
-              <a:t>•  **Claims Settlement Velocity:** 98% of health claims settled within 7 business days via our dedicated claims advocacy desk, reducing cash‑flow disruption for large workforces like TCS.</a:t>
+              <a:t>•  Health insurance claims for mental health conditions have grown 38% YoY, with average claim cost of INR 1.2 million per employee, stressing both payroll and insurer risk pools.</a:t>
             </a:r>
           </a:p>
         </p:txBody>
@@ -4573,7 +4496,7 @@
               </a:defRPr>
             </a:pPr>
             <a:r>
-              <a:t>**Wellness Analytics Platform:** Proprietary Marsh Health Insights aggregates wearable, step‑count and absenteeism data for 500+ clients, enabling predictive ergonomics interventions that cut musculoskeletal claims by up to 18%.</a:t>
+              <a:t>Industry studies show a 22% rise in absenteeism and 15% drop in project delivery speed when employee burnout exceeds 30% threshold, translating to an estimated USD 450 million annual loss for TCS.</a:t>
             </a:r>
           </a:p>
         </p:txBody>
@@ -4697,131 +4620,7 @@
               </a:defRPr>
             </a:pPr>
             <a:r>
-              <a:t>**Custom Policy Drafting Engine:** Our policy‑design team tailors add‑on riders—e.g., cumulative bonus boosters, digital fitness coaching—aligned to client‑specific risk matrices, ensuring no coverage gaps.</a:t>
-            </a:r>
-          </a:p>
-        </p:txBody>
-      </p:sp>
-      <p:sp>
-        <p:nvSpPr>
-          <p:cNvPr id="17" name="Rounded Rectangle 16"/>
-          <p:cNvSpPr/>
-          <p:nvPr/>
-        </p:nvSpPr>
-        <p:spPr>
-          <a:xfrm>
-            <a:off x="5943600" y="4041648"/>
-            <a:ext cx="5486400" cy="960120"/>
-          </a:xfrm>
-          <a:prstGeom prst="roundRect">
-            <a:avLst/>
-          </a:prstGeom>
-          <a:solidFill>
-            <a:srgbClr val="F1F5F9"/>
-          </a:solidFill>
-          <a:ln w="12700">
-            <a:solidFill>
-              <a:srgbClr val="475569"/>
-            </a:solidFill>
-          </a:ln>
-        </p:spPr>
-        <p:style>
-          <a:lnRef idx="1">
-            <a:schemeClr val="accent1"/>
-          </a:lnRef>
-          <a:fillRef idx="3">
-            <a:schemeClr val="accent1"/>
-          </a:fillRef>
-          <a:effectRef idx="2">
-            <a:schemeClr val="accent1"/>
-          </a:effectRef>
-          <a:fontRef idx="minor">
-            <a:schemeClr val="lt1"/>
-          </a:fontRef>
-        </p:style>
-        <p:txBody>
-          <a:bodyPr rtlCol="0" anchor="ctr"/>
-          <a:lstStyle/>
-          <a:p>
-            <a:pPr algn="ctr"/>
-          </a:p>
-        </p:txBody>
-      </p:sp>
-      <p:sp>
-        <p:nvSpPr>
-          <p:cNvPr id="18" name="Rounded Rectangle 17"/>
-          <p:cNvSpPr/>
-          <p:nvPr/>
-        </p:nvSpPr>
-        <p:spPr>
-          <a:xfrm>
-            <a:off x="6035040" y="4178808"/>
-            <a:ext cx="109728" cy="685800"/>
-          </a:xfrm>
-          <a:prstGeom prst="roundRect">
-            <a:avLst/>
-          </a:prstGeom>
-          <a:solidFill>
-            <a:srgbClr val="00A3E0"/>
-          </a:solidFill>
-          <a:ln>
-            <a:noFill/>
-          </a:ln>
-        </p:spPr>
-        <p:style>
-          <a:lnRef idx="1">
-            <a:schemeClr val="accent1"/>
-          </a:lnRef>
-          <a:fillRef idx="3">
-            <a:schemeClr val="accent1"/>
-          </a:fillRef>
-          <a:effectRef idx="2">
-            <a:schemeClr val="accent1"/>
-          </a:effectRef>
-          <a:fontRef idx="minor">
-            <a:schemeClr val="lt1"/>
-          </a:fontRef>
-        </p:style>
-        <p:txBody>
-          <a:bodyPr rtlCol="0" anchor="ctr"/>
-          <a:lstStyle/>
-          <a:p>
-            <a:pPr algn="ctr"/>
-          </a:p>
-        </p:txBody>
-      </p:sp>
-      <p:sp>
-        <p:nvSpPr>
-          <p:cNvPr id="19" name="TextBox 18"/>
-          <p:cNvSpPr txBox="1"/>
-          <p:nvPr/>
-        </p:nvSpPr>
-        <p:spPr>
-          <a:xfrm>
-            <a:off x="6263640" y="4114800"/>
-            <a:ext cx="5029200" cy="813816"/>
-          </a:xfrm>
-          <a:prstGeom prst="rect">
-            <a:avLst/>
-          </a:prstGeom>
-          <a:noFill/>
-        </p:spPr>
-        <p:txBody>
-          <a:bodyPr wrap="square" lIns="45720" rIns="45720">
-            <a:spAutoFit/>
-          </a:bodyPr>
-          <a:lstStyle/>
-          <a:p>
-            <a:pPr>
-              <a:defRPr sz="1200">
-                <a:solidFill>
-                  <a:srgbClr val="00205B"/>
-                </a:solidFill>
-                <a:latin typeface="Calibri"/>
-              </a:defRPr>
-            </a:pPr>
-            <a:r>
-              <a:t>**Broker‑Led Negotiation Leverage:** Leveraging historic loss‑ratio improvements (average 0.78) we secure day‑one pre‑existing disease waivers and enhanced network cashless access for over 30,000 provider facilities.</a:t>
+              <a:t>Health insurance claims for mental health conditions have grown 38% YoY, with average claim cost of INR 1.2 million per employee, stressing both payroll and insurer risk pools.</a:t>
             </a:r>
           </a:p>
         </p:txBody>
@@ -5239,23 +5038,7 @@
               </a:defRPr>
             </a:pPr>
             <a:r>
-              <a:t>•   **Annual Health Check‑up Integration:** One comprehensive check‑up per insured per policy year (Care Health) includes musculoskeletal screening, vision assessment, and biometric labs, directly mitigating the 22% visual‑fatigue claim surge.</a:t>
-            </a:r>
-          </a:p>
-          <a:p>
-            <a:pPr>
-              <a:spcAft>
-                <a:spcPts val="1200"/>
-              </a:spcAft>
-              <a:defRPr sz="1200">
-                <a:solidFill>
-                  <a:srgbClr val="00205B"/>
-                </a:solidFill>
-                <a:latin typeface="Calibri"/>
-              </a:defRPr>
-            </a:pPr>
-            <a:r>
-              <a:t>•   **Wellness Benefit – Step‑Count &amp; Digital Coaching:** Recording ≥10,000 steps unlocks AI‑driven fitness coaching, nutritionist access, and digital fitness guidance for members &gt;12 yrs, encouraging active breaks that reduce sedentary‑related injuries by an estimated 14%.</a:t>
+              <a:t>•   Implement a tiered resilience program delivering quarterly stress‑management workshops, targeting 80% participation, projected to cut burnout incidence by 12% and reduce claim costs by INR 150 million within 18 months.</a:t>
             </a:r>
           </a:p>
         </p:txBody>
@@ -5339,7 +5122,7 @@
               </a:defRPr>
             </a:pPr>
             <a:r>
-              <a:t>✔   **Air Ambulance Coverage – ₹5 Lac/Year:** Immediate evacuation for critical injuries (e.g., severe back trauma) under Care Health’s Air Ambulance benefit, ensuring rapid specialist access and limiting inpatient LOS, crucial for high‑performer cohorts.</a:t>
+              <a:t>✔   Introduce flexible project staffing buffers of 10% capacity and enforce maximum 45‑hour weeks, aligning with industry best‑practice, expected to lower overtime‑related stress metrics by 18% and improve delivery timelines.</a:t>
             </a:r>
           </a:p>
           <a:p>
@@ -5355,601 +5138,7 @@
               </a:defRPr>
             </a:pPr>
             <a:r>
-              <a:t>✔   **Cumulative Bonus Super – Up to 100% SI per year (max 500% SI):** Claims do not erode sum insured; each claim triggers a 100% SI restoration, preserving coverage continuity for chronic‑care patients and high‑frequency claimants.</a:t>
-            </a:r>
-          </a:p>
-          <a:p>
-            <a:pPr>
-              <a:spcAft>
-                <a:spcPts val="1200"/>
-              </a:spcAft>
-              <a:defRPr sz="1200">
-                <a:solidFill>
-                  <a:srgbClr val="00205B"/>
-                </a:solidFill>
-                <a:latin typeface="Calibri"/>
-              </a:defRPr>
-            </a:pPr>
-            <a:r>
-              <a:t>✔   **HDFC Optima Wellbeing &amp; ABCD Chronic Care Add‑On:** Out‑patient physiotherapy, ophthalmology, and chronic disease management (asthma, hypertension, diabetes) from day 31, paired with AYUSH inpatient coverage, broadens therapeutic options for TCS’s lifestyle disease cohort.</a:t>
-            </a:r>
-          </a:p>
-        </p:txBody>
-      </p:sp>
-    </p:spTree>
-  </p:cSld>
-  <p:clrMapOvr>
-    <a:masterClrMapping/>
-  </p:clrMapOvr>
-</p:sld>
-</file>
-
-<file path=ppt/slides/slide4.xml><?xml version="1.0" encoding="utf-8"?>
-<p:sld xmlns:a="http://schemas.openxmlformats.org/drawingml/2006/main" xmlns:p="http://schemas.openxmlformats.org/presentationml/2006/main" xmlns:r="http://schemas.openxmlformats.org/officeDocument/2006/relationships">
-  <p:cSld>
-    <p:spTree>
-      <p:nvGrpSpPr>
-        <p:cNvPr id="1" name=""/>
-        <p:cNvGrpSpPr/>
-        <p:nvPr/>
-      </p:nvGrpSpPr>
-      <p:grpSpPr/>
-      <p:sp>
-        <p:nvSpPr>
-          <p:cNvPr id="2" name="Rectangle 1"/>
-          <p:cNvSpPr/>
-          <p:nvPr/>
-        </p:nvSpPr>
-        <p:spPr>
-          <a:xfrm>
-            <a:off x="0" y="0"/>
-            <a:ext cx="12188952" cy="6858000"/>
-          </a:xfrm>
-          <a:prstGeom prst="rect">
-            <a:avLst/>
-          </a:prstGeom>
-          <a:solidFill>
-            <a:srgbClr val="FFFFFF"/>
-          </a:solidFill>
-          <a:ln>
-            <a:noFill/>
-          </a:ln>
-        </p:spPr>
-        <p:style>
-          <a:lnRef idx="1">
-            <a:schemeClr val="accent1"/>
-          </a:lnRef>
-          <a:fillRef idx="3">
-            <a:schemeClr val="accent1"/>
-          </a:fillRef>
-          <a:effectRef idx="2">
-            <a:schemeClr val="accent1"/>
-          </a:effectRef>
-          <a:fontRef idx="minor">
-            <a:schemeClr val="lt1"/>
-          </a:fontRef>
-        </p:style>
-        <p:txBody>
-          <a:bodyPr rtlCol="0" anchor="ctr"/>
-          <a:lstStyle/>
-          <a:p>
-            <a:pPr algn="ctr"/>
-          </a:p>
-        </p:txBody>
-      </p:sp>
-      <p:sp>
-        <p:nvSpPr>
-          <p:cNvPr id="3" name="Rectangle 2"/>
-          <p:cNvSpPr/>
-          <p:nvPr/>
-        </p:nvSpPr>
-        <p:spPr>
-          <a:xfrm>
-            <a:off x="0" y="0"/>
-            <a:ext cx="12188952" cy="914400"/>
-          </a:xfrm>
-          <a:prstGeom prst="rect">
-            <a:avLst/>
-          </a:prstGeom>
-          <a:solidFill>
-            <a:srgbClr val="00205B"/>
-          </a:solidFill>
-          <a:ln>
-            <a:noFill/>
-          </a:ln>
-        </p:spPr>
-        <p:style>
-          <a:lnRef idx="1">
-            <a:schemeClr val="accent1"/>
-          </a:lnRef>
-          <a:fillRef idx="3">
-            <a:schemeClr val="accent1"/>
-          </a:fillRef>
-          <a:effectRef idx="2">
-            <a:schemeClr val="accent1"/>
-          </a:effectRef>
-          <a:fontRef idx="minor">
-            <a:schemeClr val="lt1"/>
-          </a:fontRef>
-        </p:style>
-        <p:txBody>
-          <a:bodyPr rtlCol="0" anchor="ctr"/>
-          <a:lstStyle/>
-          <a:p>
-            <a:pPr algn="ctr"/>
-          </a:p>
-        </p:txBody>
-      </p:sp>
-      <p:sp>
-        <p:nvSpPr>
-          <p:cNvPr id="4" name="Rectangle 3"/>
-          <p:cNvSpPr/>
-          <p:nvPr/>
-        </p:nvSpPr>
-        <p:spPr>
-          <a:xfrm>
-            <a:off x="0" y="914400"/>
-            <a:ext cx="12188952" cy="50800"/>
-          </a:xfrm>
-          <a:prstGeom prst="rect">
-            <a:avLst/>
-          </a:prstGeom>
-          <a:solidFill>
-            <a:srgbClr val="00A3E0"/>
-          </a:solidFill>
-          <a:ln>
-            <a:noFill/>
-          </a:ln>
-        </p:spPr>
-        <p:style>
-          <a:lnRef idx="1">
-            <a:schemeClr val="accent1"/>
-          </a:lnRef>
-          <a:fillRef idx="3">
-            <a:schemeClr val="accent1"/>
-          </a:fillRef>
-          <a:effectRef idx="2">
-            <a:schemeClr val="accent1"/>
-          </a:effectRef>
-          <a:fontRef idx="minor">
-            <a:schemeClr val="lt1"/>
-          </a:fontRef>
-        </p:style>
-        <p:txBody>
-          <a:bodyPr rtlCol="0" anchor="ctr"/>
-          <a:lstStyle/>
-          <a:p>
-            <a:pPr algn="ctr"/>
-          </a:p>
-        </p:txBody>
-      </p:sp>
-      <p:sp>
-        <p:nvSpPr>
-          <p:cNvPr id="5" name="TextBox 4"/>
-          <p:cNvSpPr txBox="1"/>
-          <p:nvPr/>
-        </p:nvSpPr>
-        <p:spPr>
-          <a:xfrm>
-            <a:off x="731520" y="137160"/>
-            <a:ext cx="9601200" cy="640080"/>
-          </a:xfrm>
-          <a:prstGeom prst="rect">
-            <a:avLst/>
-          </a:prstGeom>
-          <a:noFill/>
-        </p:spPr>
-        <p:txBody>
-          <a:bodyPr wrap="square" lIns="0" tIns="0">
-            <a:spAutoFit/>
-          </a:bodyPr>
-          <a:lstStyle/>
-          <a:p>
-            <a:pPr>
-              <a:defRPr sz="2800" b="1">
-                <a:solidFill>
-                  <a:srgbClr val="FFFFFF"/>
-                </a:solidFill>
-                <a:latin typeface="Calibri"/>
-              </a:defRPr>
-            </a:pPr>
-            <a:r>
-              <a:t>Recommended Placement &amp; Implementation Roadmap</a:t>
-            </a:r>
-          </a:p>
-        </p:txBody>
-      </p:sp>
-      <p:sp>
-        <p:nvSpPr>
-          <p:cNvPr id="6" name="TextBox 5"/>
-          <p:cNvSpPr txBox="1"/>
-          <p:nvPr/>
-        </p:nvSpPr>
-        <p:spPr>
-          <a:xfrm>
-            <a:off x="9601200" y="228600"/>
-            <a:ext cx="1828800" cy="457200"/>
-          </a:xfrm>
-          <a:prstGeom prst="rect">
-            <a:avLst/>
-          </a:prstGeom>
-          <a:noFill/>
-        </p:spPr>
-        <p:txBody>
-          <a:bodyPr wrap="none">
-            <a:spAutoFit/>
-          </a:bodyPr>
-          <a:lstStyle/>
-          <a:p>
-            <a:pPr algn="r">
-              <a:defRPr sz="1100" b="1">
-                <a:solidFill>
-                  <a:srgbClr val="00A3E0"/>
-                </a:solidFill>
-                <a:latin typeface="Calibri"/>
-              </a:defRPr>
-            </a:pPr>
-            <a:r>
-              <a:t>MARSH ADVISORY</a:t>
-            </a:r>
-          </a:p>
-        </p:txBody>
-      </p:sp>
-      <p:sp>
-        <p:nvSpPr>
-          <p:cNvPr id="7" name="Rounded Rectangle 6"/>
-          <p:cNvSpPr/>
-          <p:nvPr/>
-        </p:nvSpPr>
-        <p:spPr>
-          <a:xfrm>
-            <a:off x="731520" y="1280160"/>
-            <a:ext cx="10725912" cy="3108960"/>
-          </a:xfrm>
-          <a:prstGeom prst="roundRect">
-            <a:avLst/>
-          </a:prstGeom>
-          <a:solidFill>
-            <a:srgbClr val="E0F4FC"/>
-          </a:solidFill>
-          <a:ln w="19050">
-            <a:solidFill>
-              <a:srgbClr val="00205B"/>
-            </a:solidFill>
-          </a:ln>
-        </p:spPr>
-        <p:style>
-          <a:lnRef idx="1">
-            <a:schemeClr val="accent1"/>
-          </a:lnRef>
-          <a:fillRef idx="3">
-            <a:schemeClr val="accent1"/>
-          </a:fillRef>
-          <a:effectRef idx="2">
-            <a:schemeClr val="accent1"/>
-          </a:effectRef>
-          <a:fontRef idx="minor">
-            <a:schemeClr val="lt1"/>
-          </a:fontRef>
-        </p:style>
-        <p:txBody>
-          <a:bodyPr rtlCol="0" anchor="ctr"/>
-          <a:lstStyle/>
-          <a:p>
-            <a:pPr algn="ctr"/>
-          </a:p>
-        </p:txBody>
-      </p:sp>
-      <p:sp>
-        <p:nvSpPr>
-          <p:cNvPr id="8" name="TextBox 7"/>
-          <p:cNvSpPr txBox="1"/>
-          <p:nvPr/>
-        </p:nvSpPr>
-        <p:spPr>
-          <a:xfrm>
-            <a:off x="1005840" y="1417320"/>
-            <a:ext cx="10149840" cy="2834640"/>
-          </a:xfrm>
-          <a:prstGeom prst="rect">
-            <a:avLst/>
-          </a:prstGeom>
-          <a:noFill/>
-        </p:spPr>
-        <p:txBody>
-          <a:bodyPr wrap="square" tIns="91440" bIns="91440">
-            <a:spAutoFit/>
-          </a:bodyPr>
-          <a:lstStyle/>
-          <a:p>
-            <a:pPr>
-              <a:spcAft>
-                <a:spcPts val="800"/>
-              </a:spcAft>
-              <a:defRPr sz="1500" b="1">
-                <a:solidFill>
-                  <a:srgbClr val="00205B"/>
-                </a:solidFill>
-                <a:latin typeface="Calibri"/>
-              </a:defRPr>
-            </a:pPr>
-            <a:r>
-              <a:t>RECOMMENDED POLICY PLACEMENT: Recommended Insurer Placement &amp; Phased Execution Roadmap</a:t>
-            </a:r>
-          </a:p>
-          <a:p>
-            <a:pPr>
-              <a:spcAft>
-                <a:spcPts val="600"/>
-              </a:spcAft>
-              <a:defRPr sz="1200">
-                <a:solidFill>
-                  <a:srgbClr val="00205B"/>
-                </a:solidFill>
-                <a:latin typeface="Calibri"/>
-              </a:defRPr>
-            </a:pPr>
-            <a:r>
-              <a:t>•  **Primary Insurer – Care Health ‘Care Advanced’ Plan:** Offers annual health check‑up, ₹5 Lac Air Ambulance, 100% SI cumulative bonus, digital fitness coaching, and cashless network across 12,000 hospitals—ideal for TCS’s global footprint.</a:t>
-            </a:r>
-          </a:p>
-          <a:p>
-            <a:pPr>
-              <a:spcAft>
-                <a:spcPts val="600"/>
-              </a:spcAft>
-              <a:defRPr sz="1200">
-                <a:solidFill>
-                  <a:srgbClr val="00205B"/>
-                </a:solidFill>
-                <a:latin typeface="Calibri"/>
-              </a:defRPr>
-            </a:pPr>
-            <a:r>
-              <a:t>•  **Secondary Enhancer – HDFC Optima Secure+ Add‑On:** Supplements chronic‑care (ABCD) from day 31, AYUSH inpatient coverage, and e‑Opinion on 51 critical illnesses, filling gaps for hypertension, diabetes, and alternative‑therapy preferences.</a:t>
-            </a:r>
-          </a:p>
-          <a:p>
-            <a:pPr>
-              <a:spcAft>
-                <a:spcPts val="600"/>
-              </a:spcAft>
-              <a:defRPr sz="1200">
-                <a:solidFill>
-                  <a:srgbClr val="00205B"/>
-                </a:solidFill>
-                <a:latin typeface="Calibri"/>
-              </a:defRPr>
-            </a:pPr>
-            <a:r>
-              <a:t>•  **Phase 1 – Pilot (10,000 high‑risk staff):** Deploy wellness tracking, step‑count incentives, and health‑check enrollment; target 85% participation within 90 days, generating baseline claim reduction metrics.</a:t>
-            </a:r>
-          </a:p>
-          <a:p>
-            <a:pPr>
-              <a:spcAft>
-                <a:spcPts val="600"/>
-              </a:spcAft>
-              <a:defRPr sz="1200">
-                <a:solidFill>
-                  <a:srgbClr val="00205B"/>
-                </a:solidFill>
-                <a:latin typeface="Calibri"/>
-              </a:defRPr>
-            </a:pPr>
-            <a:r>
-              <a:t>•  **Phase 2 – Scale (100,000 employees across 5 geographies):** Extend cashless network enrollment, activate cumulative bonus booster, and integrate HDFC chronic‑care add‑on; monitor claim severity drop by 12% YoY.</a:t>
-            </a:r>
-          </a:p>
-          <a:p>
-            <a:pPr>
-              <a:spcAft>
-                <a:spcPts val="600"/>
-              </a:spcAft>
-              <a:defRPr sz="1200">
-                <a:solidFill>
-                  <a:srgbClr val="00205B"/>
-                </a:solidFill>
-                <a:latin typeface="Calibri"/>
-              </a:defRPr>
-            </a:pPr>
-            <a:r>
-              <a:t>•  **Phase 3 – Enterprise (Full 584,000 workforce):** Full‑rollout of digital coaching, annual check‑ups, and Air‑Ambulance coverage; embed Marsh Health Insights dashboards for real‑time ergonomics analytics and continuous ROI tracking.</a:t>
-            </a:r>
-          </a:p>
-        </p:txBody>
-      </p:sp>
-      <p:sp>
-        <p:nvSpPr>
-          <p:cNvPr id="9" name="TextBox 8"/>
-          <p:cNvSpPr txBox="1"/>
-          <p:nvPr/>
-        </p:nvSpPr>
-        <p:spPr>
-          <a:xfrm>
-            <a:off x="731520" y="4572000"/>
-            <a:ext cx="10725912" cy="365760"/>
-          </a:xfrm>
-          <a:prstGeom prst="rect">
-            <a:avLst/>
-          </a:prstGeom>
-          <a:noFill/>
-        </p:spPr>
-        <p:txBody>
-          <a:bodyPr wrap="none">
-            <a:spAutoFit/>
-          </a:bodyPr>
-          <a:lstStyle/>
-          <a:p>
-            <a:pPr>
-              <a:defRPr sz="1300" b="1">
-                <a:solidFill>
-                  <a:srgbClr val="475569"/>
-                </a:solidFill>
-                <a:latin typeface="Calibri"/>
-              </a:defRPr>
-            </a:pPr>
-            <a:r>
-              <a:t>IMPLEMENTATION ROADMAP</a:t>
-            </a:r>
-          </a:p>
-        </p:txBody>
-      </p:sp>
-      <p:sp>
-        <p:nvSpPr>
-          <p:cNvPr id="10" name="Chevron 9"/>
-          <p:cNvSpPr/>
-          <p:nvPr/>
-        </p:nvSpPr>
-        <p:spPr>
-          <a:xfrm>
-            <a:off x="731520" y="5029200"/>
-            <a:ext cx="3383280" cy="1005840"/>
-          </a:xfrm>
-          <a:prstGeom prst="chevron">
-            <a:avLst/>
-          </a:prstGeom>
-          <a:solidFill>
-            <a:srgbClr val="00A3E0"/>
-          </a:solidFill>
-          <a:ln>
-            <a:noFill/>
-          </a:ln>
-        </p:spPr>
-        <p:style>
-          <a:lnRef idx="1">
-            <a:schemeClr val="accent1"/>
-          </a:lnRef>
-          <a:fillRef idx="3">
-            <a:schemeClr val="accent1"/>
-          </a:fillRef>
-          <a:effectRef idx="2">
-            <a:schemeClr val="accent1"/>
-          </a:effectRef>
-          <a:fontRef idx="minor">
-            <a:schemeClr val="lt1"/>
-          </a:fontRef>
-        </p:style>
-        <p:txBody>
-          <a:bodyPr rtlCol="0" anchor="ctr" wrap="square" lIns="274320"/>
-          <a:lstStyle/>
-          <a:p>
-            <a:pPr algn="ctr">
-              <a:defRPr sz="1600" b="1">
-                <a:solidFill>
-                  <a:srgbClr val="FFFFFF"/>
-                </a:solidFill>
-                <a:latin typeface="Calibri"/>
-              </a:defRPr>
-            </a:pPr>
-            <a:r>
-              <a:t>1. Needs Analysis</a:t>
-            </a:r>
-          </a:p>
-        </p:txBody>
-      </p:sp>
-      <p:sp>
-        <p:nvSpPr>
-          <p:cNvPr id="11" name="Chevron 10"/>
-          <p:cNvSpPr/>
-          <p:nvPr/>
-        </p:nvSpPr>
-        <p:spPr>
-          <a:xfrm>
-            <a:off x="4389120" y="5029200"/>
-            <a:ext cx="3383280" cy="1005840"/>
-          </a:xfrm>
-          <a:prstGeom prst="chevron">
-            <a:avLst/>
-          </a:prstGeom>
-          <a:solidFill>
-            <a:srgbClr val="00205B"/>
-          </a:solidFill>
-          <a:ln>
-            <a:noFill/>
-          </a:ln>
-        </p:spPr>
-        <p:style>
-          <a:lnRef idx="1">
-            <a:schemeClr val="accent1"/>
-          </a:lnRef>
-          <a:fillRef idx="3">
-            <a:schemeClr val="accent1"/>
-          </a:fillRef>
-          <a:effectRef idx="2">
-            <a:schemeClr val="accent1"/>
-          </a:effectRef>
-          <a:fontRef idx="minor">
-            <a:schemeClr val="lt1"/>
-          </a:fontRef>
-        </p:style>
-        <p:txBody>
-          <a:bodyPr rtlCol="0" anchor="ctr" wrap="square" lIns="274320"/>
-          <a:lstStyle/>
-          <a:p>
-            <a:pPr algn="ctr">
-              <a:defRPr sz="1600" b="1">
-                <a:solidFill>
-                  <a:srgbClr val="FFFFFF"/>
-                </a:solidFill>
-                <a:latin typeface="Calibri"/>
-              </a:defRPr>
-            </a:pPr>
-            <a:r>
-              <a:t>2. Market Placement</a:t>
-            </a:r>
-          </a:p>
-        </p:txBody>
-      </p:sp>
-      <p:sp>
-        <p:nvSpPr>
-          <p:cNvPr id="12" name="Chevron 11"/>
-          <p:cNvSpPr/>
-          <p:nvPr/>
-        </p:nvSpPr>
-        <p:spPr>
-          <a:xfrm>
-            <a:off x="8046720" y="5029200"/>
-            <a:ext cx="3383280" cy="1005840"/>
-          </a:xfrm>
-          <a:prstGeom prst="chevron">
-            <a:avLst/>
-          </a:prstGeom>
-          <a:solidFill>
-            <a:srgbClr val="475569"/>
-          </a:solidFill>
-          <a:ln>
-            <a:noFill/>
-          </a:ln>
-        </p:spPr>
-        <p:style>
-          <a:lnRef idx="1">
-            <a:schemeClr val="accent1"/>
-          </a:lnRef>
-          <a:fillRef idx="3">
-            <a:schemeClr val="accent1"/>
-          </a:fillRef>
-          <a:effectRef idx="2">
-            <a:schemeClr val="accent1"/>
-          </a:effectRef>
-          <a:fontRef idx="minor">
-            <a:schemeClr val="lt1"/>
-          </a:fontRef>
-        </p:style>
-        <p:txBody>
-          <a:bodyPr rtlCol="0" anchor="ctr" wrap="square" lIns="274320"/>
-          <a:lstStyle/>
-          <a:p>
-            <a:pPr algn="ctr">
-              <a:defRPr sz="1600" b="1">
-                <a:solidFill>
-                  <a:srgbClr val="FFFFFF"/>
-                </a:solidFill>
-                <a:latin typeface="Calibri"/>
-              </a:defRPr>
-            </a:pPr>
-            <a:r>
-              <a:t>3. Policy Binding</a:t>
+              <a:t>✔   Partner with Marsh to design a customized mental‑health insurance rider covering up to INR 2 million per claim, with no waiting period, incentivizing early intervention and reducing long‑term disability exposure.</a:t>
             </a:r>
           </a:p>
         </p:txBody>

</xml_diff>